<commit_message>
docs: update the demo deck for draft-11 and HTTPS
New slide 11 summarizes what draft-11 added (person tokens, auth tokens
with presented_token, missions by s256, revocation, four-party
federation, call chaining, the uma.lab HTTPS front). The status,
operations, method and project slides now describe the draft-11 build:
library 0.3.0, 285 tests, /auth-token, six acceptance modes over HTTPS,
https://ps.uma.lab/ui/. build_deck.py rebuilds the image deck from
slides.html with headless Chrome and python-pptx.

Co-Authored-By: Claude Opus 5.5 <noreply@anthropic.com>
</commit_message>
<xml_diff>
--- a/demo/slides/aauth-java-person-server.pptx
+++ b/demo/slides/aauth-java-person-server.pptx
@@ -17,8 +17,9 @@
     <p:sldId id="265" r:id="rId16"/>
     <p:sldId id="266" r:id="rId17"/>
     <p:sldId id="267" r:id="rId18"/>
+    <p:sldId id="268" r:id="rId19"/>
   </p:sldIdLst>
-  <p:sldSz cx="12191695" cy="6858000" type="screen4x3"/>
+  <p:sldSz cx="12192000" cy="6858000" type="screen4x3"/>
   <p:notesSz cx="6858000" cy="9144000"/>
   <p:defaultTextStyle>
     <a:defPPr>
@@ -3101,7 +3102,7 @@
       <p:grpSpPr/>
       <p:pic>
         <p:nvPicPr>
-          <p:cNvPr id="2" name="Picture 1" descr="slide-01.png"/>
+          <p:cNvPr id="2" name="Picture 1" descr="slide01.png"/>
           <p:cNvPicPr>
             <a:picLocks noChangeAspect="1"/>
           </p:cNvPicPr>
@@ -3116,7 +3117,7 @@
         <p:spPr>
           <a:xfrm>
             <a:off x="0" y="0"/>
-            <a:ext cx="12191695" cy="6858000"/>
+            <a:ext cx="12192000" cy="6858000"/>
           </a:xfrm>
           <a:prstGeom prst="rect">
             <a:avLst/>
@@ -3143,7 +3144,7 @@
       <p:grpSpPr/>
       <p:pic>
         <p:nvPicPr>
-          <p:cNvPr id="2" name="Picture 1" descr="slide-10.png"/>
+          <p:cNvPr id="2" name="Picture 1" descr="slide10.png"/>
           <p:cNvPicPr>
             <a:picLocks noChangeAspect="1"/>
           </p:cNvPicPr>
@@ -3158,7 +3159,7 @@
         <p:spPr>
           <a:xfrm>
             <a:off x="0" y="0"/>
-            <a:ext cx="12191695" cy="6858000"/>
+            <a:ext cx="12192000" cy="6858000"/>
           </a:xfrm>
           <a:prstGeom prst="rect">
             <a:avLst/>
@@ -3185,7 +3186,7 @@
       <p:grpSpPr/>
       <p:pic>
         <p:nvPicPr>
-          <p:cNvPr id="2" name="Picture 1" descr="slide-11.png"/>
+          <p:cNvPr id="2" name="Picture 1" descr="slide11.png"/>
           <p:cNvPicPr>
             <a:picLocks noChangeAspect="1"/>
           </p:cNvPicPr>
@@ -3200,7 +3201,7 @@
         <p:spPr>
           <a:xfrm>
             <a:off x="0" y="0"/>
-            <a:ext cx="12191695" cy="6858000"/>
+            <a:ext cx="12192000" cy="6858000"/>
           </a:xfrm>
           <a:prstGeom prst="rect">
             <a:avLst/>
@@ -3227,7 +3228,7 @@
       <p:grpSpPr/>
       <p:pic>
         <p:nvPicPr>
-          <p:cNvPr id="2" name="Picture 1" descr="slide-12.png"/>
+          <p:cNvPr id="2" name="Picture 1" descr="slide12.png"/>
           <p:cNvPicPr>
             <a:picLocks noChangeAspect="1"/>
           </p:cNvPicPr>
@@ -3242,7 +3243,49 @@
         <p:spPr>
           <a:xfrm>
             <a:off x="0" y="0"/>
-            <a:ext cx="12191695" cy="6858000"/>
+            <a:ext cx="12192000" cy="6858000"/>
+          </a:xfrm>
+          <a:prstGeom prst="rect">
+            <a:avLst/>
+          </a:prstGeom>
+        </p:spPr>
+      </p:pic>
+    </p:spTree>
+  </p:cSld>
+  <p:clrMapOvr>
+    <a:masterClrMapping/>
+  </p:clrMapOvr>
+</p:sld>
+</file>
+
+<file path=ppt/slides/slide13.xml><?xml version="1.0" encoding="utf-8"?>
+<p:sld xmlns:a="http://schemas.openxmlformats.org/drawingml/2006/main" xmlns:p="http://schemas.openxmlformats.org/presentationml/2006/main" xmlns:r="http://schemas.openxmlformats.org/officeDocument/2006/relationships">
+  <p:cSld>
+    <p:spTree>
+      <p:nvGrpSpPr>
+        <p:cNvPr id="1" name=""/>
+        <p:cNvGrpSpPr/>
+        <p:nvPr/>
+      </p:nvGrpSpPr>
+      <p:grpSpPr/>
+      <p:pic>
+        <p:nvPicPr>
+          <p:cNvPr id="2" name="Picture 1" descr="slide13.png"/>
+          <p:cNvPicPr>
+            <a:picLocks noChangeAspect="1"/>
+          </p:cNvPicPr>
+          <p:nvPr/>
+        </p:nvPicPr>
+        <p:blipFill>
+          <a:blip r:embed="rId2"/>
+          <a:stretch>
+            <a:fillRect/>
+          </a:stretch>
+        </p:blipFill>
+        <p:spPr>
+          <a:xfrm>
+            <a:off x="0" y="0"/>
+            <a:ext cx="12192000" cy="6858000"/>
           </a:xfrm>
           <a:prstGeom prst="rect">
             <a:avLst/>
@@ -3269,7 +3312,7 @@
       <p:grpSpPr/>
       <p:pic>
         <p:nvPicPr>
-          <p:cNvPr id="2" name="Picture 1" descr="slide-02.png"/>
+          <p:cNvPr id="2" name="Picture 1" descr="slide02.png"/>
           <p:cNvPicPr>
             <a:picLocks noChangeAspect="1"/>
           </p:cNvPicPr>
@@ -3284,7 +3327,7 @@
         <p:spPr>
           <a:xfrm>
             <a:off x="0" y="0"/>
-            <a:ext cx="12191695" cy="6858000"/>
+            <a:ext cx="12192000" cy="6858000"/>
           </a:xfrm>
           <a:prstGeom prst="rect">
             <a:avLst/>
@@ -3311,7 +3354,7 @@
       <p:grpSpPr/>
       <p:pic>
         <p:nvPicPr>
-          <p:cNvPr id="2" name="Picture 1" descr="slide-03.png"/>
+          <p:cNvPr id="2" name="Picture 1" descr="slide03.png"/>
           <p:cNvPicPr>
             <a:picLocks noChangeAspect="1"/>
           </p:cNvPicPr>
@@ -3326,7 +3369,7 @@
         <p:spPr>
           <a:xfrm>
             <a:off x="0" y="0"/>
-            <a:ext cx="12191695" cy="6858000"/>
+            <a:ext cx="12192000" cy="6858000"/>
           </a:xfrm>
           <a:prstGeom prst="rect">
             <a:avLst/>
@@ -3353,7 +3396,7 @@
       <p:grpSpPr/>
       <p:pic>
         <p:nvPicPr>
-          <p:cNvPr id="2" name="Picture 1" descr="slide-04.png"/>
+          <p:cNvPr id="2" name="Picture 1" descr="slide04.png"/>
           <p:cNvPicPr>
             <a:picLocks noChangeAspect="1"/>
           </p:cNvPicPr>
@@ -3368,7 +3411,7 @@
         <p:spPr>
           <a:xfrm>
             <a:off x="0" y="0"/>
-            <a:ext cx="12191695" cy="6858000"/>
+            <a:ext cx="12192000" cy="6858000"/>
           </a:xfrm>
           <a:prstGeom prst="rect">
             <a:avLst/>
@@ -3395,7 +3438,7 @@
       <p:grpSpPr/>
       <p:pic>
         <p:nvPicPr>
-          <p:cNvPr id="2" name="Picture 1" descr="slide-05.png"/>
+          <p:cNvPr id="2" name="Picture 1" descr="slide05.png"/>
           <p:cNvPicPr>
             <a:picLocks noChangeAspect="1"/>
           </p:cNvPicPr>
@@ -3410,7 +3453,7 @@
         <p:spPr>
           <a:xfrm>
             <a:off x="0" y="0"/>
-            <a:ext cx="12191695" cy="6858000"/>
+            <a:ext cx="12192000" cy="6858000"/>
           </a:xfrm>
           <a:prstGeom prst="rect">
             <a:avLst/>
@@ -3437,7 +3480,7 @@
       <p:grpSpPr/>
       <p:pic>
         <p:nvPicPr>
-          <p:cNvPr id="2" name="Picture 1" descr="slide-06.png"/>
+          <p:cNvPr id="2" name="Picture 1" descr="slide06.png"/>
           <p:cNvPicPr>
             <a:picLocks noChangeAspect="1"/>
           </p:cNvPicPr>
@@ -3452,7 +3495,7 @@
         <p:spPr>
           <a:xfrm>
             <a:off x="0" y="0"/>
-            <a:ext cx="12191695" cy="6858000"/>
+            <a:ext cx="12192000" cy="6858000"/>
           </a:xfrm>
           <a:prstGeom prst="rect">
             <a:avLst/>
@@ -3479,7 +3522,7 @@
       <p:grpSpPr/>
       <p:pic>
         <p:nvPicPr>
-          <p:cNvPr id="2" name="Picture 1" descr="slide-07.png"/>
+          <p:cNvPr id="2" name="Picture 1" descr="slide07.png"/>
           <p:cNvPicPr>
             <a:picLocks noChangeAspect="1"/>
           </p:cNvPicPr>
@@ -3494,7 +3537,7 @@
         <p:spPr>
           <a:xfrm>
             <a:off x="0" y="0"/>
-            <a:ext cx="12191695" cy="6858000"/>
+            <a:ext cx="12192000" cy="6858000"/>
           </a:xfrm>
           <a:prstGeom prst="rect">
             <a:avLst/>
@@ -3521,7 +3564,7 @@
       <p:grpSpPr/>
       <p:pic>
         <p:nvPicPr>
-          <p:cNvPr id="2" name="Picture 1" descr="slide-08.png"/>
+          <p:cNvPr id="2" name="Picture 1" descr="slide08.png"/>
           <p:cNvPicPr>
             <a:picLocks noChangeAspect="1"/>
           </p:cNvPicPr>
@@ -3536,7 +3579,7 @@
         <p:spPr>
           <a:xfrm>
             <a:off x="0" y="0"/>
-            <a:ext cx="12191695" cy="6858000"/>
+            <a:ext cx="12192000" cy="6858000"/>
           </a:xfrm>
           <a:prstGeom prst="rect">
             <a:avLst/>
@@ -3563,7 +3606,7 @@
       <p:grpSpPr/>
       <p:pic>
         <p:nvPicPr>
-          <p:cNvPr id="2" name="Picture 1" descr="slide-09.png"/>
+          <p:cNvPr id="2" name="Picture 1" descr="slide09.png"/>
           <p:cNvPicPr>
             <a:picLocks noChangeAspect="1"/>
           </p:cNvPicPr>
@@ -3578,7 +3621,7 @@
         <p:spPr>
           <a:xfrm>
             <a:off x="0" y="0"/>
-            <a:ext cx="12191695" cy="6858000"/>
+            <a:ext cx="12192000" cy="6858000"/>
           </a:xfrm>
           <a:prstGeom prst="rect">
             <a:avLst/>

</xml_diff>

<commit_message>
docs: update the demo deck for draft-11 and HTTPS (#15)
* docs: update the demo deck for draft-11 and HTTPS

New slide 11 summarizes what draft-11 added (person tokens, auth tokens
with presented_token, missions by s256, revocation, four-party
federation, call chaining, the uma.lab HTTPS front). The status,
operations, method and project slides now describe the draft-11 build:
library 0.3.0, 285 tests, /auth-token, six acceptance modes over HTTPS,
https://ps.uma.lab/ui/. build_deck.py rebuilds the image deck from
slides.html with headless Chrome and python-pptx.

Co-Authored-By: Claude Opus 5.5 <noreply@anthropic.com>

* docs: keep build_deck.py within 100 columns

Co-Authored-By: Claude Opus 5.5 <noreply@anthropic.com>

---------

Co-authored-by: Claude Opus 5.5 <noreply@anthropic.com>
</commit_message>
<xml_diff>
--- a/demo/slides/aauth-java-person-server.pptx
+++ b/demo/slides/aauth-java-person-server.pptx
@@ -17,8 +17,9 @@
     <p:sldId id="265" r:id="rId16"/>
     <p:sldId id="266" r:id="rId17"/>
     <p:sldId id="267" r:id="rId18"/>
+    <p:sldId id="268" r:id="rId19"/>
   </p:sldIdLst>
-  <p:sldSz cx="12191695" cy="6858000" type="screen4x3"/>
+  <p:sldSz cx="12192000" cy="6858000" type="screen4x3"/>
   <p:notesSz cx="6858000" cy="9144000"/>
   <p:defaultTextStyle>
     <a:defPPr>
@@ -3101,7 +3102,7 @@
       <p:grpSpPr/>
       <p:pic>
         <p:nvPicPr>
-          <p:cNvPr id="2" name="Picture 1" descr="slide-01.png"/>
+          <p:cNvPr id="2" name="Picture 1" descr="slide01.png"/>
           <p:cNvPicPr>
             <a:picLocks noChangeAspect="1"/>
           </p:cNvPicPr>
@@ -3116,7 +3117,7 @@
         <p:spPr>
           <a:xfrm>
             <a:off x="0" y="0"/>
-            <a:ext cx="12191695" cy="6858000"/>
+            <a:ext cx="12192000" cy="6858000"/>
           </a:xfrm>
           <a:prstGeom prst="rect">
             <a:avLst/>
@@ -3143,7 +3144,7 @@
       <p:grpSpPr/>
       <p:pic>
         <p:nvPicPr>
-          <p:cNvPr id="2" name="Picture 1" descr="slide-10.png"/>
+          <p:cNvPr id="2" name="Picture 1" descr="slide10.png"/>
           <p:cNvPicPr>
             <a:picLocks noChangeAspect="1"/>
           </p:cNvPicPr>
@@ -3158,7 +3159,7 @@
         <p:spPr>
           <a:xfrm>
             <a:off x="0" y="0"/>
-            <a:ext cx="12191695" cy="6858000"/>
+            <a:ext cx="12192000" cy="6858000"/>
           </a:xfrm>
           <a:prstGeom prst="rect">
             <a:avLst/>
@@ -3185,7 +3186,7 @@
       <p:grpSpPr/>
       <p:pic>
         <p:nvPicPr>
-          <p:cNvPr id="2" name="Picture 1" descr="slide-11.png"/>
+          <p:cNvPr id="2" name="Picture 1" descr="slide11.png"/>
           <p:cNvPicPr>
             <a:picLocks noChangeAspect="1"/>
           </p:cNvPicPr>
@@ -3200,7 +3201,7 @@
         <p:spPr>
           <a:xfrm>
             <a:off x="0" y="0"/>
-            <a:ext cx="12191695" cy="6858000"/>
+            <a:ext cx="12192000" cy="6858000"/>
           </a:xfrm>
           <a:prstGeom prst="rect">
             <a:avLst/>
@@ -3227,7 +3228,7 @@
       <p:grpSpPr/>
       <p:pic>
         <p:nvPicPr>
-          <p:cNvPr id="2" name="Picture 1" descr="slide-12.png"/>
+          <p:cNvPr id="2" name="Picture 1" descr="slide12.png"/>
           <p:cNvPicPr>
             <a:picLocks noChangeAspect="1"/>
           </p:cNvPicPr>
@@ -3242,7 +3243,49 @@
         <p:spPr>
           <a:xfrm>
             <a:off x="0" y="0"/>
-            <a:ext cx="12191695" cy="6858000"/>
+            <a:ext cx="12192000" cy="6858000"/>
+          </a:xfrm>
+          <a:prstGeom prst="rect">
+            <a:avLst/>
+          </a:prstGeom>
+        </p:spPr>
+      </p:pic>
+    </p:spTree>
+  </p:cSld>
+  <p:clrMapOvr>
+    <a:masterClrMapping/>
+  </p:clrMapOvr>
+</p:sld>
+</file>
+
+<file path=ppt/slides/slide13.xml><?xml version="1.0" encoding="utf-8"?>
+<p:sld xmlns:a="http://schemas.openxmlformats.org/drawingml/2006/main" xmlns:p="http://schemas.openxmlformats.org/presentationml/2006/main" xmlns:r="http://schemas.openxmlformats.org/officeDocument/2006/relationships">
+  <p:cSld>
+    <p:spTree>
+      <p:nvGrpSpPr>
+        <p:cNvPr id="1" name=""/>
+        <p:cNvGrpSpPr/>
+        <p:nvPr/>
+      </p:nvGrpSpPr>
+      <p:grpSpPr/>
+      <p:pic>
+        <p:nvPicPr>
+          <p:cNvPr id="2" name="Picture 1" descr="slide13.png"/>
+          <p:cNvPicPr>
+            <a:picLocks noChangeAspect="1"/>
+          </p:cNvPicPr>
+          <p:nvPr/>
+        </p:nvPicPr>
+        <p:blipFill>
+          <a:blip r:embed="rId2"/>
+          <a:stretch>
+            <a:fillRect/>
+          </a:stretch>
+        </p:blipFill>
+        <p:spPr>
+          <a:xfrm>
+            <a:off x="0" y="0"/>
+            <a:ext cx="12192000" cy="6858000"/>
           </a:xfrm>
           <a:prstGeom prst="rect">
             <a:avLst/>
@@ -3269,7 +3312,7 @@
       <p:grpSpPr/>
       <p:pic>
         <p:nvPicPr>
-          <p:cNvPr id="2" name="Picture 1" descr="slide-02.png"/>
+          <p:cNvPr id="2" name="Picture 1" descr="slide02.png"/>
           <p:cNvPicPr>
             <a:picLocks noChangeAspect="1"/>
           </p:cNvPicPr>
@@ -3284,7 +3327,7 @@
         <p:spPr>
           <a:xfrm>
             <a:off x="0" y="0"/>
-            <a:ext cx="12191695" cy="6858000"/>
+            <a:ext cx="12192000" cy="6858000"/>
           </a:xfrm>
           <a:prstGeom prst="rect">
             <a:avLst/>
@@ -3311,7 +3354,7 @@
       <p:grpSpPr/>
       <p:pic>
         <p:nvPicPr>
-          <p:cNvPr id="2" name="Picture 1" descr="slide-03.png"/>
+          <p:cNvPr id="2" name="Picture 1" descr="slide03.png"/>
           <p:cNvPicPr>
             <a:picLocks noChangeAspect="1"/>
           </p:cNvPicPr>
@@ -3326,7 +3369,7 @@
         <p:spPr>
           <a:xfrm>
             <a:off x="0" y="0"/>
-            <a:ext cx="12191695" cy="6858000"/>
+            <a:ext cx="12192000" cy="6858000"/>
           </a:xfrm>
           <a:prstGeom prst="rect">
             <a:avLst/>
@@ -3353,7 +3396,7 @@
       <p:grpSpPr/>
       <p:pic>
         <p:nvPicPr>
-          <p:cNvPr id="2" name="Picture 1" descr="slide-04.png"/>
+          <p:cNvPr id="2" name="Picture 1" descr="slide04.png"/>
           <p:cNvPicPr>
             <a:picLocks noChangeAspect="1"/>
           </p:cNvPicPr>
@@ -3368,7 +3411,7 @@
         <p:spPr>
           <a:xfrm>
             <a:off x="0" y="0"/>
-            <a:ext cx="12191695" cy="6858000"/>
+            <a:ext cx="12192000" cy="6858000"/>
           </a:xfrm>
           <a:prstGeom prst="rect">
             <a:avLst/>
@@ -3395,7 +3438,7 @@
       <p:grpSpPr/>
       <p:pic>
         <p:nvPicPr>
-          <p:cNvPr id="2" name="Picture 1" descr="slide-05.png"/>
+          <p:cNvPr id="2" name="Picture 1" descr="slide05.png"/>
           <p:cNvPicPr>
             <a:picLocks noChangeAspect="1"/>
           </p:cNvPicPr>
@@ -3410,7 +3453,7 @@
         <p:spPr>
           <a:xfrm>
             <a:off x="0" y="0"/>
-            <a:ext cx="12191695" cy="6858000"/>
+            <a:ext cx="12192000" cy="6858000"/>
           </a:xfrm>
           <a:prstGeom prst="rect">
             <a:avLst/>
@@ -3437,7 +3480,7 @@
       <p:grpSpPr/>
       <p:pic>
         <p:nvPicPr>
-          <p:cNvPr id="2" name="Picture 1" descr="slide-06.png"/>
+          <p:cNvPr id="2" name="Picture 1" descr="slide06.png"/>
           <p:cNvPicPr>
             <a:picLocks noChangeAspect="1"/>
           </p:cNvPicPr>
@@ -3452,7 +3495,7 @@
         <p:spPr>
           <a:xfrm>
             <a:off x="0" y="0"/>
-            <a:ext cx="12191695" cy="6858000"/>
+            <a:ext cx="12192000" cy="6858000"/>
           </a:xfrm>
           <a:prstGeom prst="rect">
             <a:avLst/>
@@ -3479,7 +3522,7 @@
       <p:grpSpPr/>
       <p:pic>
         <p:nvPicPr>
-          <p:cNvPr id="2" name="Picture 1" descr="slide-07.png"/>
+          <p:cNvPr id="2" name="Picture 1" descr="slide07.png"/>
           <p:cNvPicPr>
             <a:picLocks noChangeAspect="1"/>
           </p:cNvPicPr>
@@ -3494,7 +3537,7 @@
         <p:spPr>
           <a:xfrm>
             <a:off x="0" y="0"/>
-            <a:ext cx="12191695" cy="6858000"/>
+            <a:ext cx="12192000" cy="6858000"/>
           </a:xfrm>
           <a:prstGeom prst="rect">
             <a:avLst/>
@@ -3521,7 +3564,7 @@
       <p:grpSpPr/>
       <p:pic>
         <p:nvPicPr>
-          <p:cNvPr id="2" name="Picture 1" descr="slide-08.png"/>
+          <p:cNvPr id="2" name="Picture 1" descr="slide08.png"/>
           <p:cNvPicPr>
             <a:picLocks noChangeAspect="1"/>
           </p:cNvPicPr>
@@ -3536,7 +3579,7 @@
         <p:spPr>
           <a:xfrm>
             <a:off x="0" y="0"/>
-            <a:ext cx="12191695" cy="6858000"/>
+            <a:ext cx="12192000" cy="6858000"/>
           </a:xfrm>
           <a:prstGeom prst="rect">
             <a:avLst/>
@@ -3563,7 +3606,7 @@
       <p:grpSpPr/>
       <p:pic>
         <p:nvPicPr>
-          <p:cNvPr id="2" name="Picture 1" descr="slide-09.png"/>
+          <p:cNvPr id="2" name="Picture 1" descr="slide09.png"/>
           <p:cNvPicPr>
             <a:picLocks noChangeAspect="1"/>
           </p:cNvPicPr>
@@ -3578,7 +3621,7 @@
         <p:spPr>
           <a:xfrm>
             <a:off x="0" y="0"/>
-            <a:ext cx="12191695" cy="6858000"/>
+            <a:ext cx="12192000" cy="6858000"/>
           </a:xfrm>
           <a:prstGeom prst="rect">
             <a:avLst/>

</xml_diff>